<commit_message>
Add XData logo and contact email to the deck and LinkedIn image; add PDF versions
Co-Authored-By: Claude Opus 5.5 <noreply@anthropic.com>
Claude-Session: https://claude.ai/code/session_018byS1KMe1J89zyHKmq2u1u
</commit_message>
<xml_diff>
--- a/docs/XData_CI_Agent_Overview.pptx
+++ b/docs/XData_CI_Agent_Overview.pptx
@@ -114,25 +114,25 @@
   <p:extLst>
     <p:ext uri="{521415D9-36F7-43E2-AB2F-B90AF26B5E84}">
       <p14:sectionLst xmlns:p14="http://schemas.microsoft.com/office/powerpoint/2010/main">
-        <p14:section name="Overview" id="{198ccd9b-011e-50f6-626e-8b70dc7a0287}">
+        <p14:section name="Overview" id="{02debb91-65da-88c5-c1a9-c980351425fc}">
           <p14:sldIdLst>
             <p14:sldId id="256"/>
             <p14:sldId id="257"/>
           </p14:sldIdLst>
         </p14:section>
-        <p14:section name="Solution" id="{a72a798b-5814-af2d-4eba-d4b9f2570689}">
+        <p14:section name="Solution" id="{134f85f7-119c-26b2-9a86-cdedf491eacd}">
           <p14:sldIdLst>
             <p14:sldId id="258"/>
             <p14:sldId id="259"/>
           </p14:sldIdLst>
         </p14:section>
-        <p14:section name="Trust" id="{d989eebc-8a1f-57ed-83a9-653f27a6576a}">
+        <p14:section name="Trust" id="{9eb1aeea-cbbe-f62d-5840-f78dc4b5efb4}">
           <p14:sldIdLst>
             <p14:sldId id="260"/>
             <p14:sldId id="261"/>
           </p14:sldIdLst>
         </p14:section>
-        <p14:section name="Delivery" id="{2ee54954-87cd-b16f-1986-07b7c775683d}">
+        <p14:section name="Delivery" id="{b7061063-5cee-bce2-7070-a3586d6e3b43}">
           <p14:sldIdLst>
             <p14:sldId id="262"/>
             <p14:sldId id="263"/>
@@ -1525,12 +1525,36 @@
           <a:chExt cx="0" cy="0"/>
         </a:xfrm>
       </p:grpSpPr>
-      <p:sp>
-        <p:nvSpPr>
-          <p:cNvPr id="2" name="Text 0"/>
+      <p:pic>
+        <p:nvPicPr>
+          <p:cNvPr id="2" name="Image 0" descr="/tmp/claude-0/-home-user-XData-Competitive-Clinical-Intelligence-Agent/f00f93d4-903b-5466-82ee-3a1d8c1c9082/scratchpad/xdata-logo-dark-bg.png">    </p:cNvPr>
+          <p:cNvPicPr>
+            <a:picLocks noChangeAspect="1"/>
+          </p:cNvPicPr>
+          <p:nvPr/>
+        </p:nvPicPr>
+        <p:blipFill>
+          <a:blip r:embed="rId1"/>
+          <a:stretch>
+            <a:fillRect/>
+          </a:stretch>
+        </p:blipFill>
+        <p:spPr>
+          <a:xfrm>
+            <a:off x="548640" y="502920"/>
+            <a:ext cx="1625950" cy="566928"/>
+          </a:xfrm>
+          <a:prstGeom prst="rect">
+            <a:avLst/>
+          </a:prstGeom>
+        </p:spPr>
+      </p:pic>
+      <p:sp>
+        <p:nvSpPr>
+          <p:cNvPr id="3" name="Text 0"/>
           <p:cNvSpPr/>
           <p:nvPr>
-            <p:ph idx="100" type="title" hasCustomPrompt="1"/>
+            <p:ph idx="101" type="title" hasCustomPrompt="1"/>
           </p:nvPr>
         </p:nvSpPr>
         <p:spPr>
@@ -1566,10 +1590,10 @@
       </p:sp>
       <p:sp>
         <p:nvSpPr>
-          <p:cNvPr id="3" name="Text 0"/>
+          <p:cNvPr id="4" name="Text 0"/>
           <p:cNvSpPr/>
           <p:nvPr>
-            <p:ph idx="101" type="body" hasCustomPrompt="1"/>
+            <p:ph idx="102" type="body" hasCustomPrompt="1"/>
           </p:nvPr>
         </p:nvSpPr>
         <p:spPr>
@@ -1674,15 +1698,39 @@
           </a:p>
         </p:txBody>
       </p:sp>
-      <p:sp>
-        <p:nvSpPr>
-          <p:cNvPr id="3" name="Text 0"/>
+      <p:pic>
+        <p:nvPicPr>
+          <p:cNvPr id="3" name="Image 0" descr="/tmp/claude-0/-home-user-XData-Competitive-Clinical-Intelligence-Agent/f00f93d4-903b-5466-82ee-3a1d8c1c9082/scratchpad/xdata-logo-light-bg.png">    </p:cNvPr>
+          <p:cNvPicPr>
+            <a:picLocks noChangeAspect="1"/>
+          </p:cNvPicPr>
+          <p:nvPr/>
+        </p:nvPicPr>
+        <p:blipFill>
+          <a:blip r:embed="rId1"/>
+          <a:stretch>
+            <a:fillRect/>
+          </a:stretch>
+        </p:blipFill>
+        <p:spPr>
+          <a:xfrm>
+            <a:off x="548640" y="6373368"/>
+            <a:ext cx="839200" cy="292608"/>
+          </a:xfrm>
+          <a:prstGeom prst="rect">
+            <a:avLst/>
+          </a:prstGeom>
+        </p:spPr>
+      </p:pic>
+      <p:sp>
+        <p:nvSpPr>
+          <p:cNvPr id="4" name="Text 0"/>
           <p:cNvSpPr/>
           <p:nvPr/>
         </p:nvSpPr>
         <p:spPr>
           <a:xfrm>
-            <a:off x="548640" y="6400800"/>
+            <a:off x="1616440" y="6400800"/>
             <a:ext cx="6400800" cy="274320"/>
           </a:xfrm>
           <a:prstGeom prst="rect">
@@ -1704,7 +1752,7 @@
                   <a:schemeClr val="accent5"/>
                 </a:solidFill>
               </a:rPr>
-              <a:t>XData Competitive &amp; Clinical Intelligence Agent</a:t>
+              <a:t>Competitive &amp; Clinical Intelligence Agent  |  rathi.dasgupta@gmail.com</a:t>
             </a:r>
             <a:endParaRPr lang="en-US" sz="1000" dirty="0"/>
           </a:p>
@@ -1787,12 +1835,36 @@
           <a:chExt cx="0" cy="0"/>
         </a:xfrm>
       </p:grpSpPr>
-      <p:sp>
-        <p:nvSpPr>
-          <p:cNvPr id="2" name="Text 0"/>
+      <p:pic>
+        <p:nvPicPr>
+          <p:cNvPr id="2" name="Image 0" descr="/tmp/claude-0/-home-user-XData-Competitive-Clinical-Intelligence-Agent/f00f93d4-903b-5466-82ee-3a1d8c1c9082/scratchpad/xdata-logo-dark-bg.png">    </p:cNvPr>
+          <p:cNvPicPr>
+            <a:picLocks noChangeAspect="1"/>
+          </p:cNvPicPr>
+          <p:nvPr/>
+        </p:nvPicPr>
+        <p:blipFill>
+          <a:blip r:embed="rId1"/>
+          <a:stretch>
+            <a:fillRect/>
+          </a:stretch>
+        </p:blipFill>
+        <p:spPr>
+          <a:xfrm>
+            <a:off x="10200681" y="612648"/>
+            <a:ext cx="1442375" cy="502920"/>
+          </a:xfrm>
+          <a:prstGeom prst="rect">
+            <a:avLst/>
+          </a:prstGeom>
+        </p:spPr>
+      </p:pic>
+      <p:sp>
+        <p:nvSpPr>
+          <p:cNvPr id="3" name="Text 0"/>
           <p:cNvSpPr/>
           <p:nvPr>
-            <p:ph idx="100" type="title" hasCustomPrompt="1"/>
+            <p:ph idx="101" type="title" hasCustomPrompt="1"/>
           </p:nvPr>
         </p:nvSpPr>
         <p:spPr>
@@ -2226,7 +2298,7 @@
           <p:cNvPr id="2" name="Text 0"/>
           <p:cNvSpPr/>
           <p:nvPr>
-            <p:ph idx="100" type="title" hasCustomPrompt="1"/>
+            <p:ph idx="101" type="title" hasCustomPrompt="1"/>
           </p:nvPr>
         </p:nvSpPr>
         <p:spPr>
@@ -2264,7 +2336,7 @@
           <p:cNvPr id="3" name="Text 0"/>
           <p:cNvSpPr/>
           <p:nvPr>
-            <p:ph idx="101" type="body" hasCustomPrompt="1"/>
+            <p:ph idx="102" type="body" hasCustomPrompt="1"/>
           </p:nvPr>
         </p:nvSpPr>
         <p:spPr>
@@ -2534,6 +2606,66 @@
               <a:t>Shows the evidence</a:t>
             </a:r>
             <a:endParaRPr lang="en-US" sz="1500" dirty="0"/>
+          </a:p>
+        </p:txBody>
+      </p:sp>
+      <p:pic>
+        <p:nvPicPr>
+          <p:cNvPr id="13" name="email icon" descr="preencoded.png">    </p:cNvPr>
+          <p:cNvPicPr>
+            <a:picLocks noChangeAspect="1"/>
+          </p:cNvPicPr>
+          <p:nvPr/>
+        </p:nvPicPr>
+        <p:blipFill>
+          <a:blip r:embed="rId4"/>
+          <a:stretch>
+            <a:fillRect/>
+          </a:stretch>
+        </p:blipFill>
+        <p:spPr>
+          <a:xfrm>
+            <a:off x="548640" y="5870448"/>
+            <a:ext cx="274320" cy="274320"/>
+          </a:xfrm>
+          <a:prstGeom prst="rect">
+            <a:avLst/>
+          </a:prstGeom>
+        </p:spPr>
+      </p:pic>
+      <p:sp>
+        <p:nvSpPr>
+          <p:cNvPr id="14" name="Text 8"/>
+          <p:cNvSpPr txBox="1"/>
+          <p:nvPr/>
+        </p:nvSpPr>
+        <p:spPr>
+          <a:xfrm>
+            <a:off x="960120" y="5833872"/>
+            <a:ext cx="5486400" cy="365760"/>
+          </a:xfrm>
+          <a:prstGeom prst="rect">
+            <a:avLst/>
+          </a:prstGeom>
+          <a:noFill/>
+          <a:ln/>
+        </p:spPr>
+        <p:txBody>
+          <a:bodyPr wrap="square" lIns="0" tIns="0" rIns="0" bIns="0" rtlCol="0" anchor="ctr"/>
+          <a:lstStyle/>
+          <a:p>
+            <a:pPr indent="0" marL="0">
+              <a:buNone/>
+            </a:pPr>
+            <a:r>
+              <a:rPr lang="en-US" sz="1600" dirty="0">
+                <a:solidFill>
+                  <a:schemeClr val="bg1"/>
+                </a:solidFill>
+              </a:rPr>
+              <a:t>rathi.dasgupta@gmail.com</a:t>
+            </a:r>
+            <a:endParaRPr lang="en-US" sz="1600" dirty="0"/>
           </a:p>
         </p:txBody>
       </p:sp>
@@ -7434,7 +7566,7 @@
           <p:cNvPr id="2" name="Text 0"/>
           <p:cNvSpPr/>
           <p:nvPr>
-            <p:ph idx="100" type="title" hasCustomPrompt="1"/>
+            <p:ph idx="101" type="title" hasCustomPrompt="1"/>
           </p:nvPr>
         </p:nvSpPr>
         <p:spPr>
@@ -7898,14 +8030,105 @@
       </p:sp>
       <p:sp>
         <p:nvSpPr>
-          <p:cNvPr id="18" name="Text 13"/>
+          <p:cNvPr id="18" name="contact badge"/>
+          <p:cNvSpPr/>
+          <p:nvPr/>
+        </p:nvSpPr>
+        <p:spPr>
+          <a:xfrm>
+            <a:off x="548640" y="4846320"/>
+            <a:ext cx="594360" cy="594360"/>
+          </a:xfrm>
+          <a:prstGeom prst="ellipse">
+            <a:avLst/>
+          </a:prstGeom>
+          <a:solidFill>
+            <a:schemeClr val="accent1"/>
+          </a:solidFill>
+          <a:ln/>
+        </p:spPr>
+      </p:sp>
+      <p:pic>
+        <p:nvPicPr>
+          <p:cNvPr id="19" name="contact icon" descr="preencoded.png">    </p:cNvPr>
+          <p:cNvPicPr>
+            <a:picLocks noChangeAspect="1"/>
+          </p:cNvPicPr>
+          <p:nvPr/>
+        </p:nvPicPr>
+        <p:blipFill>
+          <a:blip r:embed="rId4"/>
+          <a:stretch>
+            <a:fillRect/>
+          </a:stretch>
+        </p:blipFill>
+        <p:spPr>
+          <a:xfrm>
+            <a:off x="691286" y="4988966"/>
+            <a:ext cx="309067" cy="309067"/>
+          </a:xfrm>
+          <a:prstGeom prst="rect">
+            <a:avLst/>
+          </a:prstGeom>
+        </p:spPr>
+      </p:pic>
+      <p:sp>
+        <p:nvSpPr>
+          <p:cNvPr id="20" name="Text 14"/>
           <p:cNvSpPr txBox="1"/>
           <p:nvPr/>
         </p:nvSpPr>
         <p:spPr>
           <a:xfrm>
-            <a:off x="548640" y="4846320"/>
-            <a:ext cx="11094415" cy="457200"/>
+            <a:off x="1325880" y="4846320"/>
+            <a:ext cx="8229600" cy="594360"/>
+          </a:xfrm>
+          <a:prstGeom prst="rect">
+            <a:avLst/>
+          </a:prstGeom>
+          <a:noFill/>
+          <a:ln/>
+        </p:spPr>
+        <p:txBody>
+          <a:bodyPr wrap="square" lIns="0" tIns="0" rIns="0" bIns="0" rtlCol="0" anchor="ctr"/>
+          <a:lstStyle/>
+          <a:p>
+            <a:pPr indent="0" marL="0">
+              <a:buNone/>
+            </a:pPr>
+            <a:r>
+              <a:rPr lang="en-US" sz="2000" b="1" dirty="0">
+                <a:solidFill>
+                  <a:schemeClr val="bg1"/>
+                </a:solidFill>
+              </a:rPr>
+              <a:t>Get in touch:  </a:t>
+            </a:r>
+            <a:pPr indent="0" marL="0">
+              <a:buNone/>
+            </a:pPr>
+            <a:r>
+              <a:rPr lang="en-US" sz="2000" dirty="0">
+                <a:solidFill>
+                  <a:schemeClr val="bg1"/>
+                </a:solidFill>
+              </a:rPr>
+              <a:t>rathi.dasgupta@gmail.com</a:t>
+            </a:r>
+            <a:endParaRPr lang="en-US" sz="2000" dirty="0"/>
+          </a:p>
+        </p:txBody>
+      </p:sp>
+      <p:sp>
+        <p:nvSpPr>
+          <p:cNvPr id="21" name="Text 15"/>
+          <p:cNvSpPr txBox="1"/>
+          <p:nvPr/>
+        </p:nvSpPr>
+        <p:spPr>
+          <a:xfrm>
+            <a:off x="548640" y="5715000"/>
+            <a:ext cx="11094415" cy="411480"/>
           </a:xfrm>
           <a:prstGeom prst="rect">
             <a:avLst/>

</xml_diff>

<commit_message>
Use the official XData logo in the deck and LinkedIn image
Co-Authored-By: Claude Opus 5.5 <noreply@anthropic.com>
Claude-Session: https://claude.ai/code/session_018byS1KMe1J89zyHKmq2u1u
</commit_message>
<xml_diff>
--- a/docs/XData_CI_Agent_Overview.pptx
+++ b/docs/XData_CI_Agent_Overview.pptx
@@ -114,25 +114,25 @@
   <p:extLst>
     <p:ext uri="{521415D9-36F7-43E2-AB2F-B90AF26B5E84}">
       <p14:sectionLst xmlns:p14="http://schemas.microsoft.com/office/powerpoint/2010/main">
-        <p14:section name="Overview" id="{02debb91-65da-88c5-c1a9-c980351425fc}">
+        <p14:section name="Overview" id="{75dea815-8677-df0f-c204-674a46490b48}">
           <p14:sldIdLst>
             <p14:sldId id="256"/>
             <p14:sldId id="257"/>
           </p14:sldIdLst>
         </p14:section>
-        <p14:section name="Solution" id="{134f85f7-119c-26b2-9a86-cdedf491eacd}">
+        <p14:section name="Solution" id="{9b2c9dec-36c4-9664-1d82-90162fbea170}">
           <p14:sldIdLst>
             <p14:sldId id="258"/>
             <p14:sldId id="259"/>
           </p14:sldIdLst>
         </p14:section>
-        <p14:section name="Trust" id="{9eb1aeea-cbbe-f62d-5840-f78dc4b5efb4}">
+        <p14:section name="Trust" id="{312f2fbf-0f71-7b60-d054-ad38fdcf04d7}">
           <p14:sldIdLst>
             <p14:sldId id="260"/>
             <p14:sldId id="261"/>
           </p14:sldIdLst>
         </p14:section>
-        <p14:section name="Delivery" id="{b7061063-5cee-bce2-7070-a3586d6e3b43}">
+        <p14:section name="Delivery" id="{c03be5b0-d6ce-4d27-7796-684f63dd8077}">
           <p14:sldIdLst>
             <p14:sldId id="262"/>
             <p14:sldId id="263"/>
@@ -1525,75 +1525,51 @@
           <a:chExt cx="0" cy="0"/>
         </a:xfrm>
       </p:grpSpPr>
-      <p:pic>
-        <p:nvPicPr>
-          <p:cNvPr id="2" name="Image 0" descr="/tmp/claude-0/-home-user-XData-Competitive-Clinical-Intelligence-Agent/f00f93d4-903b-5466-82ee-3a1d8c1c9082/scratchpad/xdata-logo-dark-bg.png">    </p:cNvPr>
-          <p:cNvPicPr>
-            <a:picLocks noChangeAspect="1"/>
-          </p:cNvPicPr>
-          <p:nvPr/>
-        </p:nvPicPr>
-        <p:blipFill>
-          <a:blip r:embed="rId1"/>
-          <a:stretch>
-            <a:fillRect/>
-          </a:stretch>
-        </p:blipFill>
-        <p:spPr>
-          <a:xfrm>
-            <a:off x="548640" y="502920"/>
-            <a:ext cx="1625950" cy="566928"/>
-          </a:xfrm>
-          <a:prstGeom prst="rect">
-            <a:avLst/>
-          </a:prstGeom>
-        </p:spPr>
-      </p:pic>
+      <p:sp>
+        <p:nvSpPr>
+          <p:cNvPr id="2" name="Text 0"/>
+          <p:cNvSpPr/>
+          <p:nvPr>
+            <p:ph idx="100" type="title" hasCustomPrompt="1"/>
+          </p:nvPr>
+        </p:nvSpPr>
+        <p:spPr>
+          <a:xfrm>
+            <a:off x="548640" y="1828800"/>
+            <a:ext cx="7863840" cy="1737360"/>
+          </a:xfrm>
+          <a:prstGeom prst="rect">
+            <a:avLst/>
+          </a:prstGeom>
+          <a:noFill/>
+          <a:ln/>
+        </p:spPr>
+        <p:txBody>
+          <a:bodyPr wrap="square" rtlCol="0"/>
+          <a:lstStyle>
+            <a:lvl1pPr algn="l" indent="0" marL="0">
+              <a:buNone/>
+              <a:defRPr lang="en-US" sz="4000" b="1" dirty="0">
+                <a:solidFill>
+                  <a:schemeClr val="bg1"/>
+                </a:solidFill>
+              </a:defRPr>
+            </a:lvl1pPr>
+          </a:lstStyle>
+          <a:p>
+            <a:pPr algn="l" indent="0" marL="0">
+              <a:buNone/>
+            </a:pPr>
+            <a:endParaRPr lang="en-US" sz="4000" dirty="0"/>
+          </a:p>
+        </p:txBody>
+      </p:sp>
       <p:sp>
         <p:nvSpPr>
           <p:cNvPr id="3" name="Text 0"/>
           <p:cNvSpPr/>
           <p:nvPr>
-            <p:ph idx="101" type="title" hasCustomPrompt="1"/>
-          </p:nvPr>
-        </p:nvSpPr>
-        <p:spPr>
-          <a:xfrm>
-            <a:off x="548640" y="1828800"/>
-            <a:ext cx="7863840" cy="1737360"/>
-          </a:xfrm>
-          <a:prstGeom prst="rect">
-            <a:avLst/>
-          </a:prstGeom>
-          <a:noFill/>
-          <a:ln/>
-        </p:spPr>
-        <p:txBody>
-          <a:bodyPr wrap="square" rtlCol="0"/>
-          <a:lstStyle>
-            <a:lvl1pPr algn="l" indent="0" marL="0">
-              <a:buNone/>
-              <a:defRPr lang="en-US" sz="4000" b="1" dirty="0">
-                <a:solidFill>
-                  <a:schemeClr val="bg1"/>
-                </a:solidFill>
-              </a:defRPr>
-            </a:lvl1pPr>
-          </a:lstStyle>
-          <a:p>
-            <a:pPr algn="l" indent="0" marL="0">
-              <a:buNone/>
-            </a:pPr>
-            <a:endParaRPr lang="en-US" sz="4000" dirty="0"/>
-          </a:p>
-        </p:txBody>
-      </p:sp>
-      <p:sp>
-        <p:nvSpPr>
-          <p:cNvPr id="4" name="Text 0"/>
-          <p:cNvSpPr/>
-          <p:nvPr>
-            <p:ph idx="102" type="body" hasCustomPrompt="1"/>
+            <p:ph idx="101" type="body" hasCustomPrompt="1"/>
           </p:nvPr>
         </p:nvSpPr>
         <p:spPr>
@@ -1700,7 +1676,7 @@
       </p:sp>
       <p:pic>
         <p:nvPicPr>
-          <p:cNvPr id="3" name="Image 0" descr="/tmp/claude-0/-home-user-XData-Competitive-Clinical-Intelligence-Agent/f00f93d4-903b-5466-82ee-3a1d8c1c9082/scratchpad/xdata-logo-light-bg.png">    </p:cNvPr>
+          <p:cNvPr id="3" name="Image 0" descr="/tmp/claude-0/-home-user-XData-Competitive-Clinical-Intelligence-Agent/f00f93d4-903b-5466-82ee-3a1d8c1c9082/scratchpad/xdata-official-logo.png">    </p:cNvPr>
           <p:cNvPicPr>
             <a:picLocks noChangeAspect="1"/>
           </p:cNvPicPr>
@@ -1714,8 +1690,8 @@
         </p:blipFill>
         <p:spPr>
           <a:xfrm>
-            <a:off x="548640" y="6373368"/>
-            <a:ext cx="839200" cy="292608"/>
+            <a:off x="548640" y="6291072"/>
+            <a:ext cx="427463" cy="420624"/>
           </a:xfrm>
           <a:prstGeom prst="rect">
             <a:avLst/>
@@ -1730,7 +1706,7 @@
         </p:nvSpPr>
         <p:spPr>
           <a:xfrm>
-            <a:off x="1616440" y="6400800"/>
+            <a:off x="1158983" y="6400800"/>
             <a:ext cx="6400800" cy="274320"/>
           </a:xfrm>
           <a:prstGeom prst="rect">
@@ -1835,36 +1811,12 @@
           <a:chExt cx="0" cy="0"/>
         </a:xfrm>
       </p:grpSpPr>
-      <p:pic>
-        <p:nvPicPr>
-          <p:cNvPr id="2" name="Image 0" descr="/tmp/claude-0/-home-user-XData-Competitive-Clinical-Intelligence-Agent/f00f93d4-903b-5466-82ee-3a1d8c1c9082/scratchpad/xdata-logo-dark-bg.png">    </p:cNvPr>
-          <p:cNvPicPr>
-            <a:picLocks noChangeAspect="1"/>
-          </p:cNvPicPr>
-          <p:nvPr/>
-        </p:nvPicPr>
-        <p:blipFill>
-          <a:blip r:embed="rId1"/>
-          <a:stretch>
-            <a:fillRect/>
-          </a:stretch>
-        </p:blipFill>
-        <p:spPr>
-          <a:xfrm>
-            <a:off x="10200681" y="612648"/>
-            <a:ext cx="1442375" cy="502920"/>
-          </a:xfrm>
-          <a:prstGeom prst="rect">
-            <a:avLst/>
-          </a:prstGeom>
-        </p:spPr>
-      </p:pic>
-      <p:sp>
-        <p:nvSpPr>
-          <p:cNvPr id="3" name="Text 0"/>
+      <p:sp>
+        <p:nvSpPr>
+          <p:cNvPr id="2" name="Text 0"/>
           <p:cNvSpPr/>
           <p:nvPr>
-            <p:ph idx="101" type="title" hasCustomPrompt="1"/>
+            <p:ph idx="100" type="title" hasCustomPrompt="1"/>
           </p:nvPr>
         </p:nvSpPr>
         <p:spPr>
@@ -2298,7 +2250,7 @@
           <p:cNvPr id="2" name="Text 0"/>
           <p:cNvSpPr/>
           <p:nvPr>
-            <p:ph idx="101" type="title" hasCustomPrompt="1"/>
+            <p:ph idx="100" type="title" hasCustomPrompt="1"/>
           </p:nvPr>
         </p:nvSpPr>
         <p:spPr>
@@ -2336,7 +2288,7 @@
           <p:cNvPr id="3" name="Text 0"/>
           <p:cNvSpPr/>
           <p:nvPr>
-            <p:ph idx="102" type="body" hasCustomPrompt="1"/>
+            <p:ph idx="101" type="body" hasCustomPrompt="1"/>
           </p:nvPr>
         </p:nvSpPr>
         <p:spPr>
@@ -2371,27 +2323,29 @@
       </p:sp>
       <p:sp>
         <p:nvSpPr>
-          <p:cNvPr id="4" name="promise 1 badge"/>
+          <p:cNvPr id="4" name="logo tile"/>
           <p:cNvSpPr/>
           <p:nvPr/>
         </p:nvSpPr>
         <p:spPr>
           <a:xfrm>
-            <a:off x="8915400" y="1965960"/>
-            <a:ext cx="731520" cy="731520"/>
-          </a:xfrm>
-          <a:prstGeom prst="ellipse">
-            <a:avLst/>
+            <a:off x="548640" y="411480"/>
+            <a:ext cx="1234440" cy="1234440"/>
+          </a:xfrm>
+          <a:prstGeom prst="roundRect">
+            <a:avLst>
+              <a:gd name="adj" fmla="val 8889"/>
+            </a:avLst>
           </a:prstGeom>
           <a:solidFill>
-            <a:schemeClr val="accent1"/>
+            <a:schemeClr val="bg1"/>
           </a:solidFill>
           <a:ln/>
         </p:spPr>
       </p:sp>
       <p:pic>
         <p:nvPicPr>
-          <p:cNvPr id="5" name="promise 1 icon" descr="preencoded.png">    </p:cNvPr>
+          <p:cNvPr id="5" name="XData logo" descr="/tmp/claude-0/-home-user-XData-Competitive-Clinical-Intelligence-Agent/f00f93d4-903b-5466-82ee-3a1d8c1c9082/scratchpad/xdata-official-logo.png">    </p:cNvPr>
           <p:cNvPicPr>
             <a:picLocks noChangeAspect="1"/>
           </p:cNvPicPr>
@@ -2405,8 +2359,8 @@
         </p:blipFill>
         <p:spPr>
           <a:xfrm>
-            <a:off x="9090965" y="2141525"/>
-            <a:ext cx="380390" cy="380390"/>
+            <a:off x="689145" y="559613"/>
+            <a:ext cx="953429" cy="938174"/>
           </a:xfrm>
           <a:prstGeom prst="rect">
             <a:avLst/>
@@ -2415,49 +2369,13 @@
       </p:pic>
       <p:sp>
         <p:nvSpPr>
-          <p:cNvPr id="6" name="Text 3"/>
-          <p:cNvSpPr txBox="1"/>
-          <p:nvPr/>
-        </p:nvSpPr>
-        <p:spPr>
-          <a:xfrm>
-            <a:off x="9829800" y="2075688"/>
-            <a:ext cx="1920240" cy="548640"/>
-          </a:xfrm>
-          <a:prstGeom prst="rect">
-            <a:avLst/>
-          </a:prstGeom>
-          <a:noFill/>
-          <a:ln/>
-        </p:spPr>
-        <p:txBody>
-          <a:bodyPr wrap="square" lIns="0" tIns="0" rIns="0" bIns="0" rtlCol="0" anchor="ctr"/>
-          <a:lstStyle/>
-          <a:p>
-            <a:pPr indent="0" marL="0">
-              <a:buNone/>
-            </a:pPr>
-            <a:r>
-              <a:rPr lang="en-US" sz="1500" b="1" dirty="0">
-                <a:solidFill>
-                  <a:schemeClr val="bg1"/>
-                </a:solidFill>
-              </a:rPr>
-              <a:t>Monitors live sources</a:t>
-            </a:r>
-            <a:endParaRPr lang="en-US" sz="1500" dirty="0"/>
-          </a:p>
-        </p:txBody>
-      </p:sp>
-      <p:sp>
-        <p:nvSpPr>
-          <p:cNvPr id="7" name="promise 2 badge"/>
+          <p:cNvPr id="6" name="promise 1 badge"/>
           <p:cNvSpPr/>
           <p:nvPr/>
         </p:nvSpPr>
         <p:spPr>
           <a:xfrm>
-            <a:off x="8915400" y="3017520"/>
+            <a:off x="8915400" y="1965960"/>
             <a:ext cx="731520" cy="731520"/>
           </a:xfrm>
           <a:prstGeom prst="ellipse">
@@ -2471,7 +2389,7 @@
       </p:sp>
       <p:pic>
         <p:nvPicPr>
-          <p:cNvPr id="8" name="promise 2 icon" descr="preencoded.png">    </p:cNvPr>
+          <p:cNvPr id="7" name="promise 1 icon" descr="preencoded.png">    </p:cNvPr>
           <p:cNvPicPr>
             <a:picLocks noChangeAspect="1"/>
           </p:cNvPicPr>
@@ -2485,7 +2403,7 @@
         </p:blipFill>
         <p:spPr>
           <a:xfrm>
-            <a:off x="9090965" y="3193085"/>
+            <a:off x="9090965" y="2141525"/>
             <a:ext cx="380390" cy="380390"/>
           </a:xfrm>
           <a:prstGeom prst="rect">
@@ -2495,13 +2413,13 @@
       </p:pic>
       <p:sp>
         <p:nvSpPr>
-          <p:cNvPr id="9" name="Text 5"/>
+          <p:cNvPr id="8" name="Text 4"/>
           <p:cNvSpPr txBox="1"/>
           <p:nvPr/>
         </p:nvSpPr>
         <p:spPr>
           <a:xfrm>
-            <a:off x="9829800" y="3127248"/>
+            <a:off x="9829800" y="2075688"/>
             <a:ext cx="1920240" cy="548640"/>
           </a:xfrm>
           <a:prstGeom prst="rect">
@@ -2523,7 +2441,7 @@
                   <a:schemeClr val="bg1"/>
                 </a:solidFill>
               </a:rPr>
-              <a:t>Scores impact on your drugs</a:t>
+              <a:t>Monitors live sources</a:t>
             </a:r>
             <a:endParaRPr lang="en-US" sz="1500" dirty="0"/>
           </a:p>
@@ -2531,13 +2449,13 @@
       </p:sp>
       <p:sp>
         <p:nvSpPr>
-          <p:cNvPr id="10" name="promise 3 badge"/>
+          <p:cNvPr id="9" name="promise 2 badge"/>
           <p:cNvSpPr/>
           <p:nvPr/>
         </p:nvSpPr>
         <p:spPr>
           <a:xfrm>
-            <a:off x="8915400" y="4069080"/>
+            <a:off x="8915400" y="3017520"/>
             <a:ext cx="731520" cy="731520"/>
           </a:xfrm>
           <a:prstGeom prst="ellipse">
@@ -2551,7 +2469,7 @@
       </p:sp>
       <p:pic>
         <p:nvPicPr>
-          <p:cNvPr id="11" name="promise 3 icon" descr="preencoded.png">    </p:cNvPr>
+          <p:cNvPr id="10" name="promise 2 icon" descr="preencoded.png">    </p:cNvPr>
           <p:cNvPicPr>
             <a:picLocks noChangeAspect="1"/>
           </p:cNvPicPr>
@@ -2565,7 +2483,7 @@
         </p:blipFill>
         <p:spPr>
           <a:xfrm>
-            <a:off x="9090965" y="4244645"/>
+            <a:off x="9090965" y="3193085"/>
             <a:ext cx="380390" cy="380390"/>
           </a:xfrm>
           <a:prstGeom prst="rect">
@@ -2575,13 +2493,13 @@
       </p:pic>
       <p:sp>
         <p:nvSpPr>
-          <p:cNvPr id="12" name="Text 7"/>
+          <p:cNvPr id="11" name="Text 6"/>
           <p:cNvSpPr txBox="1"/>
           <p:nvPr/>
         </p:nvSpPr>
         <p:spPr>
           <a:xfrm>
-            <a:off x="9829800" y="4178808"/>
+            <a:off x="9829800" y="3127248"/>
             <a:ext cx="1920240" cy="548640"/>
           </a:xfrm>
           <a:prstGeom prst="rect">
@@ -2603,15 +2521,35 @@
                   <a:schemeClr val="bg1"/>
                 </a:solidFill>
               </a:rPr>
-              <a:t>Shows the evidence</a:t>
+              <a:t>Scores impact on your drugs</a:t>
             </a:r>
             <a:endParaRPr lang="en-US" sz="1500" dirty="0"/>
           </a:p>
         </p:txBody>
+      </p:sp>
+      <p:sp>
+        <p:nvSpPr>
+          <p:cNvPr id="12" name="promise 3 badge"/>
+          <p:cNvSpPr/>
+          <p:nvPr/>
+        </p:nvSpPr>
+        <p:spPr>
+          <a:xfrm>
+            <a:off x="8915400" y="4069080"/>
+            <a:ext cx="731520" cy="731520"/>
+          </a:xfrm>
+          <a:prstGeom prst="ellipse">
+            <a:avLst/>
+          </a:prstGeom>
+          <a:solidFill>
+            <a:schemeClr val="accent1"/>
+          </a:solidFill>
+          <a:ln/>
+        </p:spPr>
       </p:sp>
       <p:pic>
         <p:nvPicPr>
-          <p:cNvPr id="13" name="email icon" descr="preencoded.png">    </p:cNvPr>
+          <p:cNvPr id="13" name="promise 3 icon" descr="preencoded.png">    </p:cNvPr>
           <p:cNvPicPr>
             <a:picLocks noChangeAspect="1"/>
           </p:cNvPicPr>
@@ -2625,6 +2563,66 @@
         </p:blipFill>
         <p:spPr>
           <a:xfrm>
+            <a:off x="9090965" y="4244645"/>
+            <a:ext cx="380390" cy="380390"/>
+          </a:xfrm>
+          <a:prstGeom prst="rect">
+            <a:avLst/>
+          </a:prstGeom>
+        </p:spPr>
+      </p:pic>
+      <p:sp>
+        <p:nvSpPr>
+          <p:cNvPr id="14" name="Text 8"/>
+          <p:cNvSpPr txBox="1"/>
+          <p:nvPr/>
+        </p:nvSpPr>
+        <p:spPr>
+          <a:xfrm>
+            <a:off x="9829800" y="4178808"/>
+            <a:ext cx="1920240" cy="548640"/>
+          </a:xfrm>
+          <a:prstGeom prst="rect">
+            <a:avLst/>
+          </a:prstGeom>
+          <a:noFill/>
+          <a:ln/>
+        </p:spPr>
+        <p:txBody>
+          <a:bodyPr wrap="square" lIns="0" tIns="0" rIns="0" bIns="0" rtlCol="0" anchor="ctr"/>
+          <a:lstStyle/>
+          <a:p>
+            <a:pPr indent="0" marL="0">
+              <a:buNone/>
+            </a:pPr>
+            <a:r>
+              <a:rPr lang="en-US" sz="1500" b="1" dirty="0">
+                <a:solidFill>
+                  <a:schemeClr val="bg1"/>
+                </a:solidFill>
+              </a:rPr>
+              <a:t>Shows the evidence</a:t>
+            </a:r>
+            <a:endParaRPr lang="en-US" sz="1500" dirty="0"/>
+          </a:p>
+        </p:txBody>
+      </p:sp>
+      <p:pic>
+        <p:nvPicPr>
+          <p:cNvPr id="15" name="email icon" descr="preencoded.png">    </p:cNvPr>
+          <p:cNvPicPr>
+            <a:picLocks noChangeAspect="1"/>
+          </p:cNvPicPr>
+          <p:nvPr/>
+        </p:nvPicPr>
+        <p:blipFill>
+          <a:blip r:embed="rId5"/>
+          <a:stretch>
+            <a:fillRect/>
+          </a:stretch>
+        </p:blipFill>
+        <p:spPr>
+          <a:xfrm>
             <a:off x="548640" y="5870448"/>
             <a:ext cx="274320" cy="274320"/>
           </a:xfrm>
@@ -2635,7 +2633,7 @@
       </p:pic>
       <p:sp>
         <p:nvSpPr>
-          <p:cNvPr id="14" name="Text 8"/>
+          <p:cNvPr id="16" name="Text 9"/>
           <p:cNvSpPr txBox="1"/>
           <p:nvPr/>
         </p:nvSpPr>
@@ -7566,7 +7564,7 @@
           <p:cNvPr id="2" name="Text 0"/>
           <p:cNvSpPr/>
           <p:nvPr>
-            <p:ph idx="101" type="title" hasCustomPrompt="1"/>
+            <p:ph idx="100" type="title" hasCustomPrompt="1"/>
           </p:nvPr>
         </p:nvSpPr>
         <p:spPr>
@@ -7601,51 +7599,29 @@
       </p:sp>
       <p:sp>
         <p:nvSpPr>
-          <p:cNvPr id="3" name="next 1 card"/>
+          <p:cNvPr id="3" name="logo tile"/>
           <p:cNvSpPr/>
           <p:nvPr/>
         </p:nvSpPr>
         <p:spPr>
           <a:xfrm>
-            <a:off x="548640" y="1600200"/>
-            <a:ext cx="3520440" cy="2880360"/>
+            <a:off x="10682935" y="384048"/>
+            <a:ext cx="960120" cy="960120"/>
           </a:xfrm>
           <a:prstGeom prst="roundRect">
             <a:avLst>
-              <a:gd name="adj" fmla="val 3810"/>
+              <a:gd name="adj" fmla="val 11429"/>
             </a:avLst>
           </a:prstGeom>
           <a:solidFill>
-            <a:schemeClr val="accent1">
-              <a:alpha val="30000"/>
-            </a:schemeClr>
-          </a:solidFill>
-          <a:ln/>
-        </p:spPr>
-      </p:sp>
-      <p:sp>
-        <p:nvSpPr>
-          <p:cNvPr id="4" name="next 1 badge"/>
-          <p:cNvSpPr/>
-          <p:nvPr/>
-        </p:nvSpPr>
-        <p:spPr>
-          <a:xfrm>
-            <a:off x="822960" y="1874520"/>
-            <a:ext cx="731520" cy="731520"/>
-          </a:xfrm>
-          <a:prstGeom prst="ellipse">
-            <a:avLst/>
-          </a:prstGeom>
-          <a:solidFill>
-            <a:schemeClr val="accent2"/>
+            <a:schemeClr val="bg1"/>
           </a:solidFill>
           <a:ln/>
         </p:spPr>
       </p:sp>
       <p:pic>
         <p:nvPicPr>
-          <p:cNvPr id="5" name="next 1 icon" descr="preencoded.png">    </p:cNvPr>
+          <p:cNvPr id="4" name="XData logo" descr="/tmp/claude-0/-home-user-XData-Competitive-Clinical-Intelligence-Agent/f00f93d4-903b-5466-82ee-3a1d8c1c9082/scratchpad/xdata-official-logo.png">    </p:cNvPr>
           <p:cNvPicPr>
             <a:picLocks noChangeAspect="1"/>
           </p:cNvPicPr>
@@ -7659,8 +7635,8 @@
         </p:blipFill>
         <p:spPr>
           <a:xfrm>
-            <a:off x="998525" y="2050085"/>
-            <a:ext cx="380390" cy="380390"/>
+            <a:off x="10792217" y="499262"/>
+            <a:ext cx="741556" cy="729691"/>
           </a:xfrm>
           <a:prstGeom prst="rect">
             <a:avLst/>
@@ -7669,88 +7645,13 @@
       </p:pic>
       <p:sp>
         <p:nvSpPr>
-          <p:cNvPr id="6" name="Text 3"/>
-          <p:cNvSpPr txBox="1"/>
-          <p:nvPr/>
-        </p:nvSpPr>
-        <p:spPr>
-          <a:xfrm>
-            <a:off x="822960" y="2788920"/>
-            <a:ext cx="3017520" cy="457200"/>
-          </a:xfrm>
-          <a:prstGeom prst="rect">
-            <a:avLst/>
-          </a:prstGeom>
-          <a:noFill/>
-          <a:ln/>
-        </p:spPr>
-        <p:txBody>
-          <a:bodyPr wrap="square" lIns="0" tIns="0" rIns="0" bIns="0" rtlCol="0" anchor="t"/>
-          <a:lstStyle/>
-          <a:p>
-            <a:pPr indent="0" marL="0">
-              <a:buNone/>
-            </a:pPr>
-            <a:r>
-              <a:rPr lang="en-US" sz="2000" b="1" dirty="0">
-                <a:solidFill>
-                  <a:schemeClr val="bg1"/>
-                </a:solidFill>
-                <a:latin typeface="Cambria" pitchFamily="34" charset="0"/>
-                <a:ea typeface="Cambria" pitchFamily="34" charset="-122"/>
-                <a:cs typeface="Cambria" pitchFamily="34" charset="-120"/>
-              </a:rPr>
-              <a:t>1. Install</a:t>
-            </a:r>
-            <a:endParaRPr lang="en-US" sz="2000" dirty="0"/>
-          </a:p>
-        </p:txBody>
-      </p:sp>
-      <p:sp>
-        <p:nvSpPr>
-          <p:cNvPr id="7" name="Text 4"/>
-          <p:cNvSpPr txBox="1"/>
-          <p:nvPr/>
-        </p:nvSpPr>
-        <p:spPr>
-          <a:xfrm>
-            <a:off x="822960" y="3291840"/>
-            <a:ext cx="3017520" cy="1463040"/>
-          </a:xfrm>
-          <a:prstGeom prst="rect">
-            <a:avLst/>
-          </a:prstGeom>
-          <a:noFill/>
-          <a:ln/>
-        </p:spPr>
-        <p:txBody>
-          <a:bodyPr wrap="square" lIns="0" tIns="0" rIns="0" bIns="0" rtlCol="0" anchor="t"/>
-          <a:lstStyle/>
-          <a:p>
-            <a:pPr indent="0" marL="0">
-              <a:buNone/>
-            </a:pPr>
-            <a:r>
-              <a:rPr lang="en-US" sz="1500" dirty="0">
-                <a:solidFill>
-                  <a:schemeClr val="bg1"/>
-                </a:solidFill>
-              </a:rPr>
-              <a:t>Paste one command in Terminal on a Mac. No Docker or admin rights; opens in your browser in about 5 minutes.</a:t>
-            </a:r>
-            <a:endParaRPr lang="en-US" sz="1500" dirty="0"/>
-          </a:p>
-        </p:txBody>
-      </p:sp>
-      <p:sp>
-        <p:nvSpPr>
-          <p:cNvPr id="8" name="next 2 card"/>
+          <p:cNvPr id="5" name="next 1 card"/>
           <p:cNvSpPr/>
           <p:nvPr/>
         </p:nvSpPr>
         <p:spPr>
           <a:xfrm>
-            <a:off x="4297680" y="1600200"/>
+            <a:off x="548640" y="1600200"/>
             <a:ext cx="3520440" cy="2880360"/>
           </a:xfrm>
           <a:prstGeom prst="roundRect">
@@ -7768,13 +7669,13 @@
       </p:sp>
       <p:sp>
         <p:nvSpPr>
-          <p:cNvPr id="9" name="next 2 badge"/>
+          <p:cNvPr id="6" name="next 1 badge"/>
           <p:cNvSpPr/>
           <p:nvPr/>
         </p:nvSpPr>
         <p:spPr>
           <a:xfrm>
-            <a:off x="4572000" y="1874520"/>
+            <a:off x="822960" y="1874520"/>
             <a:ext cx="731520" cy="731520"/>
           </a:xfrm>
           <a:prstGeom prst="ellipse">
@@ -7788,7 +7689,7 @@
       </p:sp>
       <p:pic>
         <p:nvPicPr>
-          <p:cNvPr id="10" name="next 2 icon" descr="preencoded.png">    </p:cNvPr>
+          <p:cNvPr id="7" name="next 1 icon" descr="preencoded.png">    </p:cNvPr>
           <p:cNvPicPr>
             <a:picLocks noChangeAspect="1"/>
           </p:cNvPicPr>
@@ -7802,7 +7703,7 @@
         </p:blipFill>
         <p:spPr>
           <a:xfrm>
-            <a:off x="4747565" y="2050085"/>
+            <a:off x="998525" y="2050085"/>
             <a:ext cx="380390" cy="380390"/>
           </a:xfrm>
           <a:prstGeom prst="rect">
@@ -7812,13 +7713,13 @@
       </p:pic>
       <p:sp>
         <p:nvSpPr>
-          <p:cNvPr id="11" name="Text 7"/>
+          <p:cNvPr id="8" name="Text 4"/>
           <p:cNvSpPr txBox="1"/>
           <p:nvPr/>
         </p:nvSpPr>
         <p:spPr>
           <a:xfrm>
-            <a:off x="4572000" y="2788920"/>
+            <a:off x="822960" y="2788920"/>
             <a:ext cx="3017520" cy="457200"/>
           </a:xfrm>
           <a:prstGeom prst="rect">
@@ -7843,7 +7744,7 @@
                 <a:ea typeface="Cambria" pitchFamily="34" charset="-122"/>
                 <a:cs typeface="Cambria" pitchFamily="34" charset="-120"/>
               </a:rPr>
-              <a:t>2. Add your drug</a:t>
+              <a:t>1. Install</a:t>
             </a:r>
             <a:endParaRPr lang="en-US" sz="2000" dirty="0"/>
           </a:p>
@@ -7851,13 +7752,13 @@
       </p:sp>
       <p:sp>
         <p:nvSpPr>
-          <p:cNvPr id="12" name="Text 8"/>
+          <p:cNvPr id="9" name="Text 5"/>
           <p:cNvSpPr txBox="1"/>
           <p:nvPr/>
         </p:nvSpPr>
         <p:spPr>
           <a:xfrm>
-            <a:off x="4572000" y="3291840"/>
+            <a:off x="822960" y="3291840"/>
             <a:ext cx="3017520" cy="1463040"/>
           </a:xfrm>
           <a:prstGeom prst="rect">
@@ -7879,7 +7780,7 @@
                   <a:schemeClr val="bg1"/>
                 </a:solidFill>
               </a:rPr>
-              <a:t>Describe target, disease, line of therapy and biomarker. Every competitor change is scored against it.</a:t>
+              <a:t>Paste one command in Terminal on a Mac. No Docker or admin rights; opens in your browser in about 5 minutes.</a:t>
             </a:r>
             <a:endParaRPr lang="en-US" sz="1500" dirty="0"/>
           </a:p>
@@ -7887,13 +7788,13 @@
       </p:sp>
       <p:sp>
         <p:nvSpPr>
-          <p:cNvPr id="13" name="next 3 card"/>
+          <p:cNvPr id="10" name="next 2 card"/>
           <p:cNvSpPr/>
           <p:nvPr/>
         </p:nvSpPr>
         <p:spPr>
           <a:xfrm>
-            <a:off x="8046720" y="1600200"/>
+            <a:off x="4297680" y="1600200"/>
             <a:ext cx="3520440" cy="2880360"/>
           </a:xfrm>
           <a:prstGeom prst="roundRect">
@@ -7911,13 +7812,13 @@
       </p:sp>
       <p:sp>
         <p:nvSpPr>
-          <p:cNvPr id="14" name="next 3 badge"/>
+          <p:cNvPr id="11" name="next 2 badge"/>
           <p:cNvSpPr/>
           <p:nvPr/>
         </p:nvSpPr>
         <p:spPr>
           <a:xfrm>
-            <a:off x="8321040" y="1874520"/>
+            <a:off x="4572000" y="1874520"/>
             <a:ext cx="731520" cy="731520"/>
           </a:xfrm>
           <a:prstGeom prst="ellipse">
@@ -7931,7 +7832,7 @@
       </p:sp>
       <p:pic>
         <p:nvPicPr>
-          <p:cNvPr id="15" name="next 3 icon" descr="preencoded.png">    </p:cNvPr>
+          <p:cNvPr id="12" name="next 2 icon" descr="preencoded.png">    </p:cNvPr>
           <p:cNvPicPr>
             <a:picLocks noChangeAspect="1"/>
           </p:cNvPicPr>
@@ -7945,7 +7846,7 @@
         </p:blipFill>
         <p:spPr>
           <a:xfrm>
-            <a:off x="8496605" y="2050085"/>
+            <a:off x="4747565" y="2050085"/>
             <a:ext cx="380390" cy="380390"/>
           </a:xfrm>
           <a:prstGeom prst="rect">
@@ -7955,13 +7856,13 @@
       </p:pic>
       <p:sp>
         <p:nvSpPr>
-          <p:cNvPr id="16" name="Text 11"/>
+          <p:cNvPr id="13" name="Text 8"/>
           <p:cNvSpPr txBox="1"/>
           <p:nvPr/>
         </p:nvSpPr>
         <p:spPr>
           <a:xfrm>
-            <a:off x="8321040" y="2788920"/>
+            <a:off x="4572000" y="2788920"/>
             <a:ext cx="3017520" cy="457200"/>
           </a:xfrm>
           <a:prstGeom prst="rect">
@@ -7986,7 +7887,7 @@
                 <a:ea typeface="Cambria" pitchFamily="34" charset="-122"/>
                 <a:cs typeface="Cambria" pitchFamily="34" charset="-120"/>
               </a:rPr>
-              <a:t>3. Tune what it watches</a:t>
+              <a:t>2. Add your drug</a:t>
             </a:r>
             <a:endParaRPr lang="en-US" sz="2000" dirty="0"/>
           </a:p>
@@ -7994,13 +7895,13 @@
       </p:sp>
       <p:sp>
         <p:nvSpPr>
-          <p:cNvPr id="17" name="Text 12"/>
+          <p:cNvPr id="14" name="Text 9"/>
           <p:cNvSpPr txBox="1"/>
           <p:nvPr/>
         </p:nvSpPr>
         <p:spPr>
           <a:xfrm>
-            <a:off x="8321040" y="3291840"/>
+            <a:off x="4572000" y="3291840"/>
             <a:ext cx="3017520" cy="1463040"/>
           </a:xfrm>
           <a:prstGeom prst="rect">
@@ -8022,7 +7923,7 @@
                   <a:schemeClr val="bg1"/>
                 </a:solidFill>
               </a:rPr>
-              <a:t>Set the trial, PubMed and FDA searches; add a Claude API key for AI-written summaries.</a:t>
+              <a:t>Describe target, disease, line of therapy and biomarker. Every competitor change is scored against it.</a:t>
             </a:r>
             <a:endParaRPr lang="en-US" sz="1500" dirty="0"/>
           </a:p>
@@ -8030,27 +7931,51 @@
       </p:sp>
       <p:sp>
         <p:nvSpPr>
-          <p:cNvPr id="18" name="contact badge"/>
+          <p:cNvPr id="15" name="next 3 card"/>
           <p:cNvSpPr/>
           <p:nvPr/>
         </p:nvSpPr>
         <p:spPr>
           <a:xfrm>
-            <a:off x="548640" y="4846320"/>
-            <a:ext cx="594360" cy="594360"/>
+            <a:off x="8046720" y="1600200"/>
+            <a:ext cx="3520440" cy="2880360"/>
+          </a:xfrm>
+          <a:prstGeom prst="roundRect">
+            <a:avLst>
+              <a:gd name="adj" fmla="val 3810"/>
+            </a:avLst>
+          </a:prstGeom>
+          <a:solidFill>
+            <a:schemeClr val="accent1">
+              <a:alpha val="30000"/>
+            </a:schemeClr>
+          </a:solidFill>
+          <a:ln/>
+        </p:spPr>
+      </p:sp>
+      <p:sp>
+        <p:nvSpPr>
+          <p:cNvPr id="16" name="next 3 badge"/>
+          <p:cNvSpPr/>
+          <p:nvPr/>
+        </p:nvSpPr>
+        <p:spPr>
+          <a:xfrm>
+            <a:off x="8321040" y="1874520"/>
+            <a:ext cx="731520" cy="731520"/>
           </a:xfrm>
           <a:prstGeom prst="ellipse">
             <a:avLst/>
           </a:prstGeom>
           <a:solidFill>
-            <a:schemeClr val="accent1"/>
+            <a:schemeClr val="accent2"/>
           </a:solidFill>
           <a:ln/>
         </p:spPr>
       </p:sp>
       <p:pic>
         <p:nvPicPr>
-          <p:cNvPr id="19" name="contact icon" descr="preencoded.png">    </p:cNvPr>
+          <p:cNvPr id="17" name="next 3 icon" descr="preencoded.png">    </p:cNvPr>
           <p:cNvPicPr>
             <a:picLocks noChangeAspect="1"/>
           </p:cNvPicPr>
@@ -8064,6 +7989,125 @@
         </p:blipFill>
         <p:spPr>
           <a:xfrm>
+            <a:off x="8496605" y="2050085"/>
+            <a:ext cx="380390" cy="380390"/>
+          </a:xfrm>
+          <a:prstGeom prst="rect">
+            <a:avLst/>
+          </a:prstGeom>
+        </p:spPr>
+      </p:pic>
+      <p:sp>
+        <p:nvSpPr>
+          <p:cNvPr id="18" name="Text 12"/>
+          <p:cNvSpPr txBox="1"/>
+          <p:nvPr/>
+        </p:nvSpPr>
+        <p:spPr>
+          <a:xfrm>
+            <a:off x="8321040" y="2788920"/>
+            <a:ext cx="3017520" cy="457200"/>
+          </a:xfrm>
+          <a:prstGeom prst="rect">
+            <a:avLst/>
+          </a:prstGeom>
+          <a:noFill/>
+          <a:ln/>
+        </p:spPr>
+        <p:txBody>
+          <a:bodyPr wrap="square" lIns="0" tIns="0" rIns="0" bIns="0" rtlCol="0" anchor="t"/>
+          <a:lstStyle/>
+          <a:p>
+            <a:pPr indent="0" marL="0">
+              <a:buNone/>
+            </a:pPr>
+            <a:r>
+              <a:rPr lang="en-US" sz="2000" b="1" dirty="0">
+                <a:solidFill>
+                  <a:schemeClr val="bg1"/>
+                </a:solidFill>
+                <a:latin typeface="Cambria" pitchFamily="34" charset="0"/>
+                <a:ea typeface="Cambria" pitchFamily="34" charset="-122"/>
+                <a:cs typeface="Cambria" pitchFamily="34" charset="-120"/>
+              </a:rPr>
+              <a:t>3. Tune what it watches</a:t>
+            </a:r>
+            <a:endParaRPr lang="en-US" sz="2000" dirty="0"/>
+          </a:p>
+        </p:txBody>
+      </p:sp>
+      <p:sp>
+        <p:nvSpPr>
+          <p:cNvPr id="19" name="Text 13"/>
+          <p:cNvSpPr txBox="1"/>
+          <p:nvPr/>
+        </p:nvSpPr>
+        <p:spPr>
+          <a:xfrm>
+            <a:off x="8321040" y="3291840"/>
+            <a:ext cx="3017520" cy="1463040"/>
+          </a:xfrm>
+          <a:prstGeom prst="rect">
+            <a:avLst/>
+          </a:prstGeom>
+          <a:noFill/>
+          <a:ln/>
+        </p:spPr>
+        <p:txBody>
+          <a:bodyPr wrap="square" lIns="0" tIns="0" rIns="0" bIns="0" rtlCol="0" anchor="t"/>
+          <a:lstStyle/>
+          <a:p>
+            <a:pPr indent="0" marL="0">
+              <a:buNone/>
+            </a:pPr>
+            <a:r>
+              <a:rPr lang="en-US" sz="1500" dirty="0">
+                <a:solidFill>
+                  <a:schemeClr val="bg1"/>
+                </a:solidFill>
+              </a:rPr>
+              <a:t>Set the trial, PubMed and FDA searches; add a Claude API key for AI-written summaries.</a:t>
+            </a:r>
+            <a:endParaRPr lang="en-US" sz="1500" dirty="0"/>
+          </a:p>
+        </p:txBody>
+      </p:sp>
+      <p:sp>
+        <p:nvSpPr>
+          <p:cNvPr id="20" name="contact badge"/>
+          <p:cNvSpPr/>
+          <p:nvPr/>
+        </p:nvSpPr>
+        <p:spPr>
+          <a:xfrm>
+            <a:off x="548640" y="4846320"/>
+            <a:ext cx="594360" cy="594360"/>
+          </a:xfrm>
+          <a:prstGeom prst="ellipse">
+            <a:avLst/>
+          </a:prstGeom>
+          <a:solidFill>
+            <a:schemeClr val="accent1"/>
+          </a:solidFill>
+          <a:ln/>
+        </p:spPr>
+      </p:sp>
+      <p:pic>
+        <p:nvPicPr>
+          <p:cNvPr id="21" name="contact icon" descr="preencoded.png">    </p:cNvPr>
+          <p:cNvPicPr>
+            <a:picLocks noChangeAspect="1"/>
+          </p:cNvPicPr>
+          <p:nvPr/>
+        </p:nvPicPr>
+        <p:blipFill>
+          <a:blip r:embed="rId5"/>
+          <a:stretch>
+            <a:fillRect/>
+          </a:stretch>
+        </p:blipFill>
+        <p:spPr>
+          <a:xfrm>
             <a:off x="691286" y="4988966"/>
             <a:ext cx="309067" cy="309067"/>
           </a:xfrm>
@@ -8074,7 +8118,7 @@
       </p:pic>
       <p:sp>
         <p:nvSpPr>
-          <p:cNvPr id="20" name="Text 14"/>
+          <p:cNvPr id="22" name="Text 15"/>
           <p:cNvSpPr txBox="1"/>
           <p:nvPr/>
         </p:nvSpPr>
@@ -8121,7 +8165,7 @@
       </p:sp>
       <p:sp>
         <p:nvSpPr>
-          <p:cNvPr id="21" name="Text 15"/>
+          <p:cNvPr id="23" name="Text 16"/>
           <p:cNvSpPr txBox="1"/>
           <p:nvPr/>
         </p:nvSpPr>

</xml_diff>

<commit_message>
Rebrand deck and LinkedIn image to the XData logo colours; logo on every slide
Co-Authored-By: Claude Opus 5.5 <noreply@anthropic.com>
Claude-Session: https://claude.ai/code/session_018byS1KMe1J89zyHKmq2u1u
</commit_message>
<xml_diff>
--- a/docs/XData_CI_Agent_Overview.pptx
+++ b/docs/XData_CI_Agent_Overview.pptx
@@ -114,25 +114,25 @@
   <p:extLst>
     <p:ext uri="{521415D9-36F7-43E2-AB2F-B90AF26B5E84}">
       <p14:sectionLst xmlns:p14="http://schemas.microsoft.com/office/powerpoint/2010/main">
-        <p14:section name="Overview" id="{75dea815-8677-df0f-c204-674a46490b48}">
+        <p14:section name="Overview" id="{a7fe7db3-0491-338b-853b-7c0c962952c8}">
           <p14:sldIdLst>
             <p14:sldId id="256"/>
             <p14:sldId id="257"/>
           </p14:sldIdLst>
         </p14:section>
-        <p14:section name="Solution" id="{9b2c9dec-36c4-9664-1d82-90162fbea170}">
+        <p14:section name="Solution" id="{c83e356f-db0f-3637-a348-1545a9952d17}">
           <p14:sldIdLst>
             <p14:sldId id="258"/>
             <p14:sldId id="259"/>
           </p14:sldIdLst>
         </p14:section>
-        <p14:section name="Trust" id="{312f2fbf-0f71-7b60-d054-ad38fdcf04d7}">
+        <p14:section name="Trust" id="{54dab094-970f-d7da-5bb1-6788e2d6c974}">
           <p14:sldIdLst>
             <p14:sldId id="260"/>
             <p14:sldId id="261"/>
           </p14:sldIdLst>
         </p14:section>
-        <p14:section name="Delivery" id="{c03be5b0-d6ce-4d27-7796-684f63dd8077}">
+        <p14:section name="Delivery" id="{a9721af6-3feb-57c3-3378-848bff87dd49}">
           <p14:sldIdLst>
             <p14:sldId id="262"/>
             <p14:sldId id="263"/>
@@ -161,7 +161,7 @@
             <a:pPr>
               <a:defRPr sz="1400" b="0" i="0" u="none" strike="noStrike">
                 <a:solidFill>
-                  <a:srgbClr val="0B3B47"/>
+                  <a:srgbClr val="0D2B5C"/>
                 </a:solidFill>
                 <a:latin typeface="+mn-lt"/>
               </a:defRPr>
@@ -169,7 +169,7 @@
             <a:r>
               <a:rPr sz="1400" b="0" i="0" u="none" strike="noStrike">
                 <a:solidFill>
-                  <a:srgbClr val="0B3B47"/>
+                  <a:srgbClr val="0D2B5C"/>
                 </a:solidFill>
                 <a:latin typeface="+mn-lt"/>
               </a:rPr>
@@ -204,7 +204,7 @@
           </c:tx>
           <c:spPr>
             <a:solidFill>
-              <a:srgbClr val="0F7C7A"/>
+              <a:srgbClr val="2F6FE0"/>
             </a:solidFill>
             <a:effectLst/>
           </c:spPr>
@@ -218,7 +218,7 @@
                 <a:pPr>
                   <a:defRPr b="0" i="0" strike="noStrike" sz="1300" u="none">
                     <a:solidFill>
-                      <a:srgbClr val="14232E"/>
+                      <a:srgbClr val="14213D"/>
                     </a:solidFill>
                     <a:latin typeface="+mn-lt"/>
                   </a:defRPr>
@@ -292,7 +292,7 @@
               <a:pPr>
                 <a:defRPr b="0" i="0" strike="noStrike" sz="1300" u="none">
                   <a:solidFill>
-                    <a:srgbClr val="14232E"/>
+                    <a:srgbClr val="14213D"/>
                   </a:solidFill>
                   <a:latin typeface="+mn-lt"/>
                 </a:defRPr>
@@ -340,7 +340,7 @@
             <a:pPr>
               <a:defRPr sz="1300" b="0" i="0" u="none" strike="noStrike">
                 <a:solidFill>
-                  <a:srgbClr val="14232E"/>
+                  <a:srgbClr val="14213D"/>
                 </a:solidFill>
                 <a:latin typeface="+mn-lt"/>
               </a:defRPr>
@@ -1646,7 +1646,7 @@
         <p:spPr>
           <a:xfrm>
             <a:off x="548640" y="365760"/>
-            <a:ext cx="11094415" cy="822960"/>
+            <a:ext cx="9997135" cy="822960"/>
           </a:xfrm>
           <a:prstGeom prst="rect">
             <a:avLst/>
@@ -1659,7 +1659,7 @@
           <a:lstStyle>
             <a:lvl1pPr algn="l" indent="0" marL="0">
               <a:buNone/>
-              <a:defRPr lang="en-US" sz="3200" b="1" dirty="0">
+              <a:defRPr lang="en-US" sz="3000" b="1" dirty="0">
                 <a:solidFill>
                   <a:schemeClr val="tx2"/>
                 </a:solidFill>
@@ -1670,7 +1670,7 @@
             <a:pPr algn="l" indent="0" marL="0">
               <a:buNone/>
             </a:pPr>
-            <a:endParaRPr lang="en-US" sz="3200" dirty="0"/>
+            <a:endParaRPr lang="en-US" sz="3000" dirty="0"/>
           </a:p>
         </p:txBody>
       </p:sp>
@@ -1690,8 +1690,8 @@
         </p:blipFill>
         <p:spPr>
           <a:xfrm>
-            <a:off x="548640" y="6291072"/>
-            <a:ext cx="427463" cy="420624"/>
+            <a:off x="10806714" y="365760"/>
+            <a:ext cx="836341" cy="822960"/>
           </a:xfrm>
           <a:prstGeom prst="rect">
             <a:avLst/>
@@ -1706,8 +1706,8 @@
         </p:nvSpPr>
         <p:spPr>
           <a:xfrm>
-            <a:off x="1158983" y="6400800"/>
-            <a:ext cx="6400800" cy="274320"/>
+            <a:off x="548640" y="6400800"/>
+            <a:ext cx="7315200" cy="274320"/>
           </a:xfrm>
           <a:prstGeom prst="rect">
             <a:avLst/>
@@ -1728,7 +1728,7 @@
                   <a:schemeClr val="accent5"/>
                 </a:solidFill>
               </a:rPr>
-              <a:t>Competitive &amp; Clinical Intelligence Agent  |  rathi.dasgupta@gmail.com</a:t>
+              <a:t>XData Competitive &amp; Clinical Intelligence Agent  |  rathi.dasgupta@gmail.com</a:t>
             </a:r>
             <a:endParaRPr lang="en-US" sz="1000" dirty="0"/>
           </a:p>
@@ -2703,7 +2703,7 @@
         <p:spPr>
           <a:xfrm>
             <a:off x="548640" y="365760"/>
-            <a:ext cx="11094415" cy="822960"/>
+            <a:ext cx="9997135" cy="822960"/>
           </a:xfrm>
           <a:prstGeom prst="rect">
             <a:avLst/>
@@ -2719,14 +2719,14 @@
               <a:buNone/>
             </a:pPr>
             <a:r>
-              <a:rPr lang="en-US" sz="3200" b="1" dirty="0">
+              <a:rPr lang="en-US" sz="3000" b="1" dirty="0">
                 <a:solidFill>
                   <a:schemeClr val="tx2"/>
                 </a:solidFill>
               </a:rPr>
-              <a:t>Competitive intelligence teams are buried in source updates</a:t>
-            </a:r>
-            <a:endParaRPr lang="en-US" sz="3200" dirty="0"/>
+              <a:t>Intelligence teams are buried in source updates</a:t>
+            </a:r>
+            <a:endParaRPr lang="en-US" sz="3000" dirty="0"/>
           </a:p>
         </p:txBody>
       </p:sp>
@@ -3375,7 +3375,7 @@
         <p:spPr>
           <a:xfrm>
             <a:off x="548640" y="365760"/>
-            <a:ext cx="11094415" cy="822960"/>
+            <a:ext cx="9997135" cy="822960"/>
           </a:xfrm>
           <a:prstGeom prst="rect">
             <a:avLst/>
@@ -3391,14 +3391,14 @@
               <a:buNone/>
             </a:pPr>
             <a:r>
-              <a:rPr lang="en-US" sz="3200" b="1" dirty="0">
+              <a:rPr lang="en-US" sz="3000" b="1" dirty="0">
                 <a:solidFill>
                   <a:schemeClr val="tx2"/>
                 </a:solidFill>
               </a:rPr>
-              <a:t>How it works: from a source update to a decision-ready alert</a:t>
-            </a:r>
-            <a:endParaRPr lang="en-US" sz="3200" dirty="0"/>
+              <a:t>How it works: from source update to decision-ready alert</a:t>
+            </a:r>
+            <a:endParaRPr lang="en-US" sz="3000" dirty="0"/>
           </a:p>
         </p:txBody>
       </p:sp>
@@ -4429,7 +4429,7 @@
         <p:spPr>
           <a:xfrm>
             <a:off x="548640" y="365760"/>
-            <a:ext cx="11094415" cy="822960"/>
+            <a:ext cx="9997135" cy="822960"/>
           </a:xfrm>
           <a:prstGeom prst="rect">
             <a:avLst/>
@@ -4445,14 +4445,14 @@
               <a:buNone/>
             </a:pPr>
             <a:r>
-              <a:rPr lang="en-US" sz="3200" b="1" dirty="0">
+              <a:rPr lang="en-US" sz="3000" b="1" dirty="0">
                 <a:solidFill>
                   <a:schemeClr val="tx2"/>
                 </a:solidFill>
               </a:rPr>
               <a:t>Example: one trial update becomes an Executive Alert</a:t>
             </a:r>
-            <a:endParaRPr lang="en-US" sz="3200" dirty="0"/>
+            <a:endParaRPr lang="en-US" sz="3000" dirty="0"/>
           </a:p>
         </p:txBody>
       </p:sp>
@@ -4542,7 +4542,7 @@
                   <a:tcPr marL="91440" marR="91440" marT="45720" marB="45720" anchor="ctr">
                     <a:lnL w="9525" cap="flat" cmpd="sng" algn="ctr">
                       <a:solidFill>
-                        <a:srgbClr val="EEF5F4"/>
+                        <a:srgbClr val="EEF4FF"/>
                       </a:solidFill>
                       <a:prstDash val="solid"/>
                       <a:round/>
@@ -4551,7 +4551,7 @@
                     </a:lnL>
                     <a:lnR w="9525" cap="flat" cmpd="sng" algn="ctr">
                       <a:solidFill>
-                        <a:srgbClr val="EEF5F4"/>
+                        <a:srgbClr val="EEF4FF"/>
                       </a:solidFill>
                       <a:prstDash val="solid"/>
                       <a:round/>
@@ -4560,7 +4560,7 @@
                     </a:lnR>
                     <a:lnT w="9525" cap="flat" cmpd="sng" algn="ctr">
                       <a:solidFill>
-                        <a:srgbClr val="EEF5F4"/>
+                        <a:srgbClr val="EEF4FF"/>
                       </a:solidFill>
                       <a:prstDash val="solid"/>
                       <a:round/>
@@ -4569,7 +4569,7 @@
                     </a:lnT>
                     <a:lnB w="9525" cap="flat" cmpd="sng" algn="ctr">
                       <a:solidFill>
-                        <a:srgbClr val="EEF5F4"/>
+                        <a:srgbClr val="EEF4FF"/>
                       </a:solidFill>
                       <a:prstDash val="solid"/>
                       <a:round/>
@@ -4603,7 +4603,7 @@
                   <a:tcPr marL="91440" marR="91440" marT="45720" marB="45720" anchor="ctr">
                     <a:lnL w="9525" cap="flat" cmpd="sng" algn="ctr">
                       <a:solidFill>
-                        <a:srgbClr val="EEF5F4"/>
+                        <a:srgbClr val="EEF4FF"/>
                       </a:solidFill>
                       <a:prstDash val="solid"/>
                       <a:round/>
@@ -4612,7 +4612,7 @@
                     </a:lnL>
                     <a:lnR w="9525" cap="flat" cmpd="sng" algn="ctr">
                       <a:solidFill>
-                        <a:srgbClr val="EEF5F4"/>
+                        <a:srgbClr val="EEF4FF"/>
                       </a:solidFill>
                       <a:prstDash val="solid"/>
                       <a:round/>
@@ -4621,7 +4621,7 @@
                     </a:lnR>
                     <a:lnT w="9525" cap="flat" cmpd="sng" algn="ctr">
                       <a:solidFill>
-                        <a:srgbClr val="EEF5F4"/>
+                        <a:srgbClr val="EEF4FF"/>
                       </a:solidFill>
                       <a:prstDash val="solid"/>
                       <a:round/>
@@ -4630,7 +4630,7 @@
                     </a:lnT>
                     <a:lnB w="9525" cap="flat" cmpd="sng" algn="ctr">
                       <a:solidFill>
-                        <a:srgbClr val="EEF5F4"/>
+                        <a:srgbClr val="EEF4FF"/>
                       </a:solidFill>
                       <a:prstDash val="solid"/>
                       <a:round/>
@@ -4664,7 +4664,7 @@
                   <a:tcPr marL="91440" marR="91440" marT="45720" marB="45720" anchor="ctr">
                     <a:lnL w="9525" cap="flat" cmpd="sng" algn="ctr">
                       <a:solidFill>
-                        <a:srgbClr val="EEF5F4"/>
+                        <a:srgbClr val="EEF4FF"/>
                       </a:solidFill>
                       <a:prstDash val="solid"/>
                       <a:round/>
@@ -4673,7 +4673,7 @@
                     </a:lnL>
                     <a:lnR w="9525" cap="flat" cmpd="sng" algn="ctr">
                       <a:solidFill>
-                        <a:srgbClr val="EEF5F4"/>
+                        <a:srgbClr val="EEF4FF"/>
                       </a:solidFill>
                       <a:prstDash val="solid"/>
                       <a:round/>
@@ -4682,7 +4682,7 @@
                     </a:lnR>
                     <a:lnT w="9525" cap="flat" cmpd="sng" algn="ctr">
                       <a:solidFill>
-                        <a:srgbClr val="EEF5F4"/>
+                        <a:srgbClr val="EEF4FF"/>
                       </a:solidFill>
                       <a:prstDash val="solid"/>
                       <a:round/>
@@ -4691,7 +4691,7 @@
                     </a:lnT>
                     <a:lnB w="9525" cap="flat" cmpd="sng" algn="ctr">
                       <a:solidFill>
-                        <a:srgbClr val="EEF5F4"/>
+                        <a:srgbClr val="EEF4FF"/>
                       </a:solidFill>
                       <a:prstDash val="solid"/>
                       <a:round/>
@@ -4727,7 +4727,7 @@
                   <a:tcPr marL="91440" marR="91440" marT="45720" marB="45720" anchor="ctr">
                     <a:lnL w="9525" cap="flat" cmpd="sng" algn="ctr">
                       <a:solidFill>
-                        <a:srgbClr val="EEF5F4"/>
+                        <a:srgbClr val="EEF4FF"/>
                       </a:solidFill>
                       <a:prstDash val="solid"/>
                       <a:round/>
@@ -4736,7 +4736,7 @@
                     </a:lnL>
                     <a:lnR w="9525" cap="flat" cmpd="sng" algn="ctr">
                       <a:solidFill>
-                        <a:srgbClr val="EEF5F4"/>
+                        <a:srgbClr val="EEF4FF"/>
                       </a:solidFill>
                       <a:prstDash val="solid"/>
                       <a:round/>
@@ -4745,7 +4745,7 @@
                     </a:lnR>
                     <a:lnT w="9525" cap="flat" cmpd="sng" algn="ctr">
                       <a:solidFill>
-                        <a:srgbClr val="EEF5F4"/>
+                        <a:srgbClr val="EEF4FF"/>
                       </a:solidFill>
                       <a:prstDash val="solid"/>
                       <a:round/>
@@ -4754,7 +4754,7 @@
                     </a:lnT>
                     <a:lnB w="9525" cap="flat" cmpd="sng" algn="ctr">
                       <a:solidFill>
-                        <a:srgbClr val="EEF5F4"/>
+                        <a:srgbClr val="EEF4FF"/>
                       </a:solidFill>
                       <a:prstDash val="solid"/>
                       <a:round/>
@@ -4788,7 +4788,7 @@
                   <a:tcPr marL="91440" marR="91440" marT="45720" marB="45720" anchor="ctr">
                     <a:lnL w="9525" cap="flat" cmpd="sng" algn="ctr">
                       <a:solidFill>
-                        <a:srgbClr val="EEF5F4"/>
+                        <a:srgbClr val="EEF4FF"/>
                       </a:solidFill>
                       <a:prstDash val="solid"/>
                       <a:round/>
@@ -4797,7 +4797,7 @@
                     </a:lnL>
                     <a:lnR w="9525" cap="flat" cmpd="sng" algn="ctr">
                       <a:solidFill>
-                        <a:srgbClr val="EEF5F4"/>
+                        <a:srgbClr val="EEF4FF"/>
                       </a:solidFill>
                       <a:prstDash val="solid"/>
                       <a:round/>
@@ -4806,7 +4806,7 @@
                     </a:lnR>
                     <a:lnT w="9525" cap="flat" cmpd="sng" algn="ctr">
                       <a:solidFill>
-                        <a:srgbClr val="EEF5F4"/>
+                        <a:srgbClr val="EEF4FF"/>
                       </a:solidFill>
                       <a:prstDash val="solid"/>
                       <a:round/>
@@ -4815,7 +4815,7 @@
                     </a:lnT>
                     <a:lnB w="9525" cap="flat" cmpd="sng" algn="ctr">
                       <a:solidFill>
-                        <a:srgbClr val="EEF5F4"/>
+                        <a:srgbClr val="EEF4FF"/>
                       </a:solidFill>
                       <a:prstDash val="solid"/>
                       <a:round/>
@@ -4849,7 +4849,7 @@
                   <a:tcPr marL="91440" marR="91440" marT="45720" marB="45720" anchor="ctr">
                     <a:lnL w="9525" cap="flat" cmpd="sng" algn="ctr">
                       <a:solidFill>
-                        <a:srgbClr val="EEF5F4"/>
+                        <a:srgbClr val="EEF4FF"/>
                       </a:solidFill>
                       <a:prstDash val="solid"/>
                       <a:round/>
@@ -4858,7 +4858,7 @@
                     </a:lnL>
                     <a:lnR w="9525" cap="flat" cmpd="sng" algn="ctr">
                       <a:solidFill>
-                        <a:srgbClr val="EEF5F4"/>
+                        <a:srgbClr val="EEF4FF"/>
                       </a:solidFill>
                       <a:prstDash val="solid"/>
                       <a:round/>
@@ -4867,7 +4867,7 @@
                     </a:lnR>
                     <a:lnT w="9525" cap="flat" cmpd="sng" algn="ctr">
                       <a:solidFill>
-                        <a:srgbClr val="EEF5F4"/>
+                        <a:srgbClr val="EEF4FF"/>
                       </a:solidFill>
                       <a:prstDash val="solid"/>
                       <a:round/>
@@ -4876,7 +4876,7 @@
                     </a:lnT>
                     <a:lnB w="9525" cap="flat" cmpd="sng" algn="ctr">
                       <a:solidFill>
-                        <a:srgbClr val="EEF5F4"/>
+                        <a:srgbClr val="EEF4FF"/>
                       </a:solidFill>
                       <a:prstDash val="solid"/>
                       <a:round/>
@@ -4912,7 +4912,7 @@
                   <a:tcPr marL="91440" marR="91440" marT="45720" marB="45720" anchor="ctr">
                     <a:lnL w="9525" cap="flat" cmpd="sng" algn="ctr">
                       <a:solidFill>
-                        <a:srgbClr val="EEF5F4"/>
+                        <a:srgbClr val="EEF4FF"/>
                       </a:solidFill>
                       <a:prstDash val="solid"/>
                       <a:round/>
@@ -4921,7 +4921,7 @@
                     </a:lnL>
                     <a:lnR w="9525" cap="flat" cmpd="sng" algn="ctr">
                       <a:solidFill>
-                        <a:srgbClr val="EEF5F4"/>
+                        <a:srgbClr val="EEF4FF"/>
                       </a:solidFill>
                       <a:prstDash val="solid"/>
                       <a:round/>
@@ -4930,7 +4930,7 @@
                     </a:lnR>
                     <a:lnT w="9525" cap="flat" cmpd="sng" algn="ctr">
                       <a:solidFill>
-                        <a:srgbClr val="EEF5F4"/>
+                        <a:srgbClr val="EEF4FF"/>
                       </a:solidFill>
                       <a:prstDash val="solid"/>
                       <a:round/>
@@ -4939,7 +4939,7 @@
                     </a:lnT>
                     <a:lnB w="9525" cap="flat" cmpd="sng" algn="ctr">
                       <a:solidFill>
-                        <a:srgbClr val="EEF5F4"/>
+                        <a:srgbClr val="EEF4FF"/>
                       </a:solidFill>
                       <a:prstDash val="solid"/>
                       <a:round/>
@@ -4973,7 +4973,7 @@
                   <a:tcPr marL="91440" marR="91440" marT="45720" marB="45720" anchor="ctr">
                     <a:lnL w="9525" cap="flat" cmpd="sng" algn="ctr">
                       <a:solidFill>
-                        <a:srgbClr val="EEF5F4"/>
+                        <a:srgbClr val="EEF4FF"/>
                       </a:solidFill>
                       <a:prstDash val="solid"/>
                       <a:round/>
@@ -4982,7 +4982,7 @@
                     </a:lnL>
                     <a:lnR w="9525" cap="flat" cmpd="sng" algn="ctr">
                       <a:solidFill>
-                        <a:srgbClr val="EEF5F4"/>
+                        <a:srgbClr val="EEF4FF"/>
                       </a:solidFill>
                       <a:prstDash val="solid"/>
                       <a:round/>
@@ -4991,7 +4991,7 @@
                     </a:lnR>
                     <a:lnT w="9525" cap="flat" cmpd="sng" algn="ctr">
                       <a:solidFill>
-                        <a:srgbClr val="EEF5F4"/>
+                        <a:srgbClr val="EEF4FF"/>
                       </a:solidFill>
                       <a:prstDash val="solid"/>
                       <a:round/>
@@ -5000,7 +5000,7 @@
                     </a:lnT>
                     <a:lnB w="9525" cap="flat" cmpd="sng" algn="ctr">
                       <a:solidFill>
-                        <a:srgbClr val="EEF5F4"/>
+                        <a:srgbClr val="EEF4FF"/>
                       </a:solidFill>
                       <a:prstDash val="solid"/>
                       <a:round/>
@@ -5034,7 +5034,7 @@
                   <a:tcPr marL="91440" marR="91440" marT="45720" marB="45720" anchor="ctr">
                     <a:lnL w="9525" cap="flat" cmpd="sng" algn="ctr">
                       <a:solidFill>
-                        <a:srgbClr val="EEF5F4"/>
+                        <a:srgbClr val="EEF4FF"/>
                       </a:solidFill>
                       <a:prstDash val="solid"/>
                       <a:round/>
@@ -5043,7 +5043,7 @@
                     </a:lnL>
                     <a:lnR w="9525" cap="flat" cmpd="sng" algn="ctr">
                       <a:solidFill>
-                        <a:srgbClr val="EEF5F4"/>
+                        <a:srgbClr val="EEF4FF"/>
                       </a:solidFill>
                       <a:prstDash val="solid"/>
                       <a:round/>
@@ -5052,7 +5052,7 @@
                     </a:lnR>
                     <a:lnT w="9525" cap="flat" cmpd="sng" algn="ctr">
                       <a:solidFill>
-                        <a:srgbClr val="EEF5F4"/>
+                        <a:srgbClr val="EEF4FF"/>
                       </a:solidFill>
                       <a:prstDash val="solid"/>
                       <a:round/>
@@ -5061,7 +5061,7 @@
                     </a:lnT>
                     <a:lnB w="9525" cap="flat" cmpd="sng" algn="ctr">
                       <a:solidFill>
-                        <a:srgbClr val="EEF5F4"/>
+                        <a:srgbClr val="EEF4FF"/>
                       </a:solidFill>
                       <a:prstDash val="solid"/>
                       <a:round/>
@@ -5097,7 +5097,7 @@
                   <a:tcPr marL="91440" marR="91440" marT="45720" marB="45720" anchor="ctr">
                     <a:lnL w="9525" cap="flat" cmpd="sng" algn="ctr">
                       <a:solidFill>
-                        <a:srgbClr val="EEF5F4"/>
+                        <a:srgbClr val="EEF4FF"/>
                       </a:solidFill>
                       <a:prstDash val="solid"/>
                       <a:round/>
@@ -5106,7 +5106,7 @@
                     </a:lnL>
                     <a:lnR w="9525" cap="flat" cmpd="sng" algn="ctr">
                       <a:solidFill>
-                        <a:srgbClr val="EEF5F4"/>
+                        <a:srgbClr val="EEF4FF"/>
                       </a:solidFill>
                       <a:prstDash val="solid"/>
                       <a:round/>
@@ -5115,7 +5115,7 @@
                     </a:lnR>
                     <a:lnT w="9525" cap="flat" cmpd="sng" algn="ctr">
                       <a:solidFill>
-                        <a:srgbClr val="EEF5F4"/>
+                        <a:srgbClr val="EEF4FF"/>
                       </a:solidFill>
                       <a:prstDash val="solid"/>
                       <a:round/>
@@ -5124,7 +5124,7 @@
                     </a:lnT>
                     <a:lnB w="9525" cap="flat" cmpd="sng" algn="ctr">
                       <a:solidFill>
-                        <a:srgbClr val="EEF5F4"/>
+                        <a:srgbClr val="EEF4FF"/>
                       </a:solidFill>
                       <a:prstDash val="solid"/>
                       <a:round/>
@@ -5158,7 +5158,7 @@
                   <a:tcPr marL="91440" marR="91440" marT="45720" marB="45720" anchor="ctr">
                     <a:lnL w="9525" cap="flat" cmpd="sng" algn="ctr">
                       <a:solidFill>
-                        <a:srgbClr val="EEF5F4"/>
+                        <a:srgbClr val="EEF4FF"/>
                       </a:solidFill>
                       <a:prstDash val="solid"/>
                       <a:round/>
@@ -5167,7 +5167,7 @@
                     </a:lnL>
                     <a:lnR w="9525" cap="flat" cmpd="sng" algn="ctr">
                       <a:solidFill>
-                        <a:srgbClr val="EEF5F4"/>
+                        <a:srgbClr val="EEF4FF"/>
                       </a:solidFill>
                       <a:prstDash val="solid"/>
                       <a:round/>
@@ -5176,7 +5176,7 @@
                     </a:lnR>
                     <a:lnT w="9525" cap="flat" cmpd="sng" algn="ctr">
                       <a:solidFill>
-                        <a:srgbClr val="EEF5F4"/>
+                        <a:srgbClr val="EEF4FF"/>
                       </a:solidFill>
                       <a:prstDash val="solid"/>
                       <a:round/>
@@ -5185,7 +5185,7 @@
                     </a:lnT>
                     <a:lnB w="9525" cap="flat" cmpd="sng" algn="ctr">
                       <a:solidFill>
-                        <a:srgbClr val="EEF5F4"/>
+                        <a:srgbClr val="EEF4FF"/>
                       </a:solidFill>
                       <a:prstDash val="solid"/>
                       <a:round/>
@@ -5219,7 +5219,7 @@
                   <a:tcPr marL="91440" marR="91440" marT="45720" marB="45720" anchor="ctr">
                     <a:lnL w="9525" cap="flat" cmpd="sng" algn="ctr">
                       <a:solidFill>
-                        <a:srgbClr val="EEF5F4"/>
+                        <a:srgbClr val="EEF4FF"/>
                       </a:solidFill>
                       <a:prstDash val="solid"/>
                       <a:round/>
@@ -5228,7 +5228,7 @@
                     </a:lnL>
                     <a:lnR w="9525" cap="flat" cmpd="sng" algn="ctr">
                       <a:solidFill>
-                        <a:srgbClr val="EEF5F4"/>
+                        <a:srgbClr val="EEF4FF"/>
                       </a:solidFill>
                       <a:prstDash val="solid"/>
                       <a:round/>
@@ -5237,7 +5237,7 @@
                     </a:lnR>
                     <a:lnT w="9525" cap="flat" cmpd="sng" algn="ctr">
                       <a:solidFill>
-                        <a:srgbClr val="EEF5F4"/>
+                        <a:srgbClr val="EEF4FF"/>
                       </a:solidFill>
                       <a:prstDash val="solid"/>
                       <a:round/>
@@ -5246,7 +5246,7 @@
                     </a:lnT>
                     <a:lnB w="9525" cap="flat" cmpd="sng" algn="ctr">
                       <a:solidFill>
-                        <a:srgbClr val="EEF5F4"/>
+                        <a:srgbClr val="EEF4FF"/>
                       </a:solidFill>
                       <a:prstDash val="solid"/>
                       <a:round/>
@@ -5607,7 +5607,7 @@
         <p:spPr>
           <a:xfrm>
             <a:off x="548640" y="365760"/>
-            <a:ext cx="11094415" cy="822960"/>
+            <a:ext cx="9997135" cy="822960"/>
           </a:xfrm>
           <a:prstGeom prst="rect">
             <a:avLst/>
@@ -5623,14 +5623,14 @@
               <a:buNone/>
             </a:pPr>
             <a:r>
-              <a:rPr lang="en-US" sz="3200" b="1" dirty="0">
+              <a:rPr lang="en-US" sz="3000" b="1" dirty="0">
                 <a:solidFill>
                   <a:schemeClr val="tx2"/>
                 </a:solidFill>
               </a:rPr>
               <a:t>Every score explains itself: the 93 points, factor by factor</a:t>
             </a:r>
-            <a:endParaRPr lang="en-US" sz="3200" dirty="0"/>
+            <a:endParaRPr lang="en-US" sz="3000" dirty="0"/>
           </a:p>
         </p:txBody>
       </p:sp>
@@ -6079,7 +6079,7 @@
         <p:spPr>
           <a:xfrm>
             <a:off x="548640" y="365760"/>
-            <a:ext cx="11094415" cy="822960"/>
+            <a:ext cx="9997135" cy="822960"/>
           </a:xfrm>
           <a:prstGeom prst="rect">
             <a:avLst/>
@@ -6095,14 +6095,14 @@
               <a:buNone/>
             </a:pPr>
             <a:r>
-              <a:rPr lang="en-US" sz="3200" b="1" dirty="0">
+              <a:rPr lang="en-US" sz="3000" b="1" dirty="0">
                 <a:solidFill>
                   <a:schemeClr val="tx2"/>
                 </a:solidFill>
               </a:rPr>
               <a:t>AI that cites its sources and says "I don't know"</a:t>
             </a:r>
-            <a:endParaRPr lang="en-US" sz="3200" dirty="0"/>
+            <a:endParaRPr lang="en-US" sz="3000" dirty="0"/>
           </a:p>
         </p:txBody>
       </p:sp>
@@ -6772,7 +6772,7 @@
         <p:spPr>
           <a:xfrm>
             <a:off x="548640" y="365760"/>
-            <a:ext cx="11094415" cy="822960"/>
+            <a:ext cx="9997135" cy="822960"/>
           </a:xfrm>
           <a:prstGeom prst="rect">
             <a:avLst/>
@@ -6788,14 +6788,14 @@
               <a:buNone/>
             </a:pPr>
             <a:r>
-              <a:rPr lang="en-US" sz="3200" b="1" dirty="0">
+              <a:rPr lang="en-US" sz="3000" b="1" dirty="0">
                 <a:solidFill>
                   <a:schemeClr val="tx2"/>
                 </a:solidFill>
               </a:rPr>
               <a:t>Built for production, not a prototype</a:t>
             </a:r>
-            <a:endParaRPr lang="en-US" sz="3200" dirty="0"/>
+            <a:endParaRPr lang="en-US" sz="3000" dirty="0"/>
           </a:p>
         </p:txBody>
       </p:sp>
@@ -8253,47 +8253,47 @@
 </file>
 
 <file path=ppt/theme/theme1.xml><?xml version="1.0" encoding="utf-8"?>
-<a:theme xmlns:a="http://schemas.openxmlformats.org/drawingml/2006/main" name="XData Clinical">
+<a:theme xmlns:a="http://schemas.openxmlformats.org/drawingml/2006/main" name="XData Brand">
   <a:themeElements>
-    <a:clrScheme name="XData Clinical">
+    <a:clrScheme name="XData Brand">
       <a:dk1>
-        <a:srgbClr val="14232E"/>
+        <a:srgbClr val="14213D"/>
       </a:dk1>
       <a:lt1>
         <a:srgbClr val="FFFFFF"/>
       </a:lt1>
       <a:dk2>
-        <a:srgbClr val="0B3B47"/>
+        <a:srgbClr val="0D2B5C"/>
       </a:dk2>
       <a:lt2>
-        <a:srgbClr val="EEF5F4"/>
+        <a:srgbClr val="EEF4FF"/>
       </a:lt2>
       <a:accent1>
-        <a:srgbClr val="0F7C7A"/>
+        <a:srgbClr val="2F6FE0"/>
       </a:accent1>
       <a:accent2>
-        <a:srgbClr val="E4572E"/>
+        <a:srgbClr val="ED2326"/>
       </a:accent2>
       <a:accent3>
-        <a:srgbClr val="6BBFB2"/>
+        <a:srgbClr val="8FB9FF"/>
       </a:accent3>
       <a:accent4>
         <a:srgbClr val="F2A541"/>
       </a:accent4>
       <a:accent5>
-        <a:srgbClr val="4C6A78"/>
+        <a:srgbClr val="4A5B78"/>
       </a:accent5>
       <a:accent6>
-        <a:srgbClr val="9FB8C2"/>
+        <a:srgbClr val="A9B6CC"/>
       </a:accent6>
       <a:hlink>
-        <a:srgbClr val="0F7C7A"/>
+        <a:srgbClr val="2F6FE0"/>
       </a:hlink>
       <a:folHlink>
-        <a:srgbClr val="4C6A78"/>
+        <a:srgbClr val="4A5B78"/>
       </a:folHlink>
     </a:clrScheme>
-    <a:fontScheme name="XData Clinical">
+    <a:fontScheme name="XData Brand">
       <a:majorFont>
         <a:latin typeface="Cambria"/>
         <a:ea typeface=""/>

</xml_diff>